<commit_message>
Actualiza documentos de Fase 1
</commit_message>
<xml_diff>
--- a/Fase 1/Evidencias grupales/Ramirez_Karla_Presentación Proyecto.pptx
+++ b/Fase 1/Evidencias grupales/Ramirez_Karla_Presentación Proyecto.pptx
@@ -2697,6 +2697,26 @@
                 <a:ea typeface="Calibri" pitchFamily="34" charset="-122"/>
                 <a:cs typeface="Calibri" pitchFamily="34" charset="-120"/>
               </a:rPr>
+              <a:t>Docker</a:t>
+            </a:r>
+          </a:p>
+          <a:p>
+            <a:pPr marL="342900" indent="-342900">
+              <a:spcAft>
+                <a:spcPts val="1000"/>
+              </a:spcAft>
+              <a:buSzPct val="100000"/>
+              <a:buChar char="■"/>
+            </a:pPr>
+            <a:r>
+              <a:rPr lang="en-US" sz="1400" dirty="0">
+                <a:solidFill>
+                  <a:srgbClr val="393D42"/>
+                </a:solidFill>
+                <a:latin typeface="Calibri" pitchFamily="34" charset="0"/>
+                <a:ea typeface="Calibri" pitchFamily="34" charset="-122"/>
+                <a:cs typeface="Calibri" pitchFamily="34" charset="-120"/>
+              </a:rPr>
               <a:t>PostgreSQL</a:t>
             </a:r>
             <a:endParaRPr lang="en-US" sz="1400" dirty="0"/>
@@ -3226,7 +3246,7 @@
                 <a:ea typeface="Calibri" pitchFamily="34" charset="-122"/>
                 <a:cs typeface="Calibri" pitchFamily="34" charset="-120"/>
               </a:rPr>
-              <a:t>Revisión continua de security hotspots con SonarQube en ambos proyectos.</a:t>
+              <a:t>Revisión continua de security hotspots con SonarQube.</a:t>
             </a:r>
             <a:endParaRPr lang="en-US" sz="1400" dirty="0"/>
           </a:p>
@@ -3520,9 +3540,6 @@
           <a:bodyPr wrap="square" lIns="0" tIns="0" rIns="0" bIns="0" rtlCol="0" anchor="ctr"/>
           <a:lstStyle/>
           <a:p>
-            <a:pPr marL="0" indent="0">
-              <a:buNone/>
-            </a:pPr>
             <a:r>
               <a:rPr lang="en-US" sz="3000" b="1" dirty="0">
                 <a:solidFill>
@@ -3532,9 +3549,29 @@
                 <a:ea typeface="Cambria" pitchFamily="34" charset="-122"/>
                 <a:cs typeface="Cambria" pitchFamily="34" charset="-120"/>
               </a:rPr>
-              <a:t>KANBAN</a:t>
-            </a:r>
-            <a:endParaRPr lang="en-US" sz="3000" dirty="0"/>
+              <a:t>KANBAN </a:t>
+            </a:r>
+            <a:r>
+              <a:rPr lang="en-US" sz="2400" i="1" dirty="0">
+                <a:latin typeface="Cambria" pitchFamily="34" charset="0"/>
+                <a:ea typeface="Cambria" pitchFamily="34" charset="-122"/>
+                <a:cs typeface="Cambria" pitchFamily="34" charset="-120"/>
+              </a:rPr>
+              <a:t>(</a:t>
+            </a:r>
+            <a:r>
+              <a:rPr lang="es-ES" sz="2400" i="1" dirty="0"/>
+              <a:t>con hitos contractuales</a:t>
+            </a:r>
+            <a:r>
+              <a:rPr lang="en-US" sz="2400" i="1" dirty="0">
+                <a:latin typeface="Cambria" pitchFamily="34" charset="0"/>
+                <a:ea typeface="Cambria" pitchFamily="34" charset="-122"/>
+                <a:cs typeface="Cambria" pitchFamily="34" charset="-120"/>
+              </a:rPr>
+              <a:t>)</a:t>
+            </a:r>
+            <a:endParaRPr lang="en-US" sz="3000" i="1" dirty="0"/>
           </a:p>
         </p:txBody>
       </p:sp>
@@ -3559,219 +3596,118 @@
           <a:bodyPr wrap="square" lIns="0" tIns="0" rIns="0" bIns="0" rtlCol="0" anchor="t"/>
           <a:lstStyle/>
           <a:p>
-            <a:pPr marL="342900" indent="-342900">
-              <a:spcAft>
-                <a:spcPts val="1200"/>
-              </a:spcAft>
-              <a:buSzPct val="100000"/>
-              <a:buChar char="■"/>
-            </a:pPr>
-            <a:r>
-              <a:rPr lang="en-US" sz="1500" dirty="0">
-                <a:solidFill>
-                  <a:srgbClr val="393D42"/>
-                </a:solidFill>
-                <a:latin typeface="Calibri" pitchFamily="34" charset="0"/>
-                <a:ea typeface="Calibri" pitchFamily="34" charset="-122"/>
-                <a:cs typeface="Calibri" pitchFamily="34" charset="-120"/>
-              </a:rPr>
+            <a:pPr marL="800100" lvl="1" indent="-342900">
+              <a:lnSpc>
+                <a:spcPct val="200000"/>
+              </a:lnSpc>
+              <a:buFont typeface="Wingdings" panose="05000000000000000000" pitchFamily="2" charset="2"/>
+              <a:buChar char="§"/>
+            </a:pPr>
+            <a:r>
+              <a:rPr lang="es-ES" sz="1600" dirty="0"/>
               <a:t>Backlog priorizado con jerarquía Épica → Historia de Usuario → Tarea.</a:t>
             </a:r>
-            <a:endParaRPr lang="en-US" sz="1500" dirty="0"/>
-          </a:p>
-          <a:p>
-            <a:pPr marL="342900" indent="-342900">
-              <a:spcAft>
-                <a:spcPts val="1200"/>
-              </a:spcAft>
-              <a:buSzPct val="100000"/>
-              <a:buChar char="■"/>
-            </a:pPr>
-            <a:r>
-              <a:rPr lang="en-US" sz="1500" dirty="0">
-                <a:solidFill>
-                  <a:srgbClr val="393D42"/>
-                </a:solidFill>
-                <a:latin typeface="Calibri" pitchFamily="34" charset="0"/>
-                <a:ea typeface="Calibri" pitchFamily="34" charset="-122"/>
-                <a:cs typeface="Calibri" pitchFamily="34" charset="-120"/>
-              </a:rPr>
+          </a:p>
+          <a:p>
+            <a:pPr marL="800100" lvl="1" indent="-342900">
+              <a:lnSpc>
+                <a:spcPct val="200000"/>
+              </a:lnSpc>
+              <a:buFont typeface="Wingdings" panose="05000000000000000000" pitchFamily="2" charset="2"/>
+              <a:buChar char="§"/>
+            </a:pPr>
+            <a:r>
+              <a:rPr lang="es-ES" sz="1600" dirty="0"/>
               <a:t>Tablero con estados: Por Hacer / En desarrollo / Terminado.</a:t>
             </a:r>
-            <a:endParaRPr lang="en-US" sz="1500" dirty="0"/>
-          </a:p>
-          <a:p>
-            <a:pPr marL="342900" indent="-342900">
-              <a:spcAft>
-                <a:spcPts val="1200"/>
-              </a:spcAft>
-              <a:buSzPct val="100000"/>
-              <a:buChar char="■"/>
-            </a:pPr>
-            <a:r>
-              <a:rPr lang="en-US" sz="1500" dirty="0">
-                <a:solidFill>
-                  <a:srgbClr val="393D42"/>
-                </a:solidFill>
-                <a:latin typeface="Calibri" pitchFamily="34" charset="0"/>
-                <a:ea typeface="Calibri" pitchFamily="34" charset="-122"/>
-                <a:cs typeface="Calibri" pitchFamily="34" charset="-120"/>
-              </a:rPr>
-              <a:t>Checkpoints semanales documentados como "sprint" para trazabilidad (Sprint Backlog, Burndown), sin ceremonias formales de Scrum.</a:t>
-            </a:r>
-            <a:endParaRPr lang="en-US" sz="1500" dirty="0"/>
-          </a:p>
-          <a:p>
-            <a:pPr marL="342900" indent="-342900">
-              <a:spcAft>
-                <a:spcPts val="1200"/>
-              </a:spcAft>
-              <a:buSzPct val="100000"/>
-              <a:buChar char="■"/>
-            </a:pPr>
-            <a:r>
-              <a:rPr lang="en-US" sz="1500" dirty="0">
-                <a:solidFill>
-                  <a:srgbClr val="393D42"/>
-                </a:solidFill>
-                <a:latin typeface="Calibri" pitchFamily="34" charset="0"/>
-                <a:ea typeface="Calibri" pitchFamily="34" charset="-122"/>
-                <a:cs typeface="Calibri" pitchFamily="34" charset="-120"/>
-              </a:rPr>
-              <a:t>Sin daily meetings ni sprint planning con equipo, al trabajar en solitario — </a:t>
-            </a:r>
-            <a:r>
-              <a:rPr lang="en-US" sz="1500" dirty="0" err="1">
-                <a:solidFill>
-                  <a:srgbClr val="393D42"/>
-                </a:solidFill>
-                <a:latin typeface="Calibri" pitchFamily="34" charset="0"/>
-                <a:ea typeface="Calibri" pitchFamily="34" charset="-122"/>
-                <a:cs typeface="Calibri" pitchFamily="34" charset="-120"/>
-              </a:rPr>
-              <a:t>evidencia</a:t>
-            </a:r>
-            <a:r>
-              <a:rPr lang="en-US" sz="1500" dirty="0">
-                <a:solidFill>
-                  <a:srgbClr val="393D42"/>
-                </a:solidFill>
-                <a:latin typeface="Calibri" pitchFamily="34" charset="0"/>
-                <a:ea typeface="Calibri" pitchFamily="34" charset="-122"/>
-                <a:cs typeface="Calibri" pitchFamily="34" charset="-120"/>
-              </a:rPr>
-              <a:t> </a:t>
-            </a:r>
-            <a:r>
-              <a:rPr lang="en-US" sz="1500" dirty="0" err="1">
-                <a:solidFill>
-                  <a:srgbClr val="393D42"/>
-                </a:solidFill>
-                <a:latin typeface="Calibri" pitchFamily="34" charset="0"/>
-                <a:ea typeface="Calibri" pitchFamily="34" charset="-122"/>
-                <a:cs typeface="Calibri" pitchFamily="34" charset="-120"/>
-              </a:rPr>
-              <a:t>será</a:t>
-            </a:r>
-            <a:r>
-              <a:rPr lang="en-US" sz="1500" dirty="0">
-                <a:solidFill>
-                  <a:srgbClr val="393D42"/>
-                </a:solidFill>
-                <a:latin typeface="Calibri" pitchFamily="34" charset="0"/>
-                <a:ea typeface="Calibri" pitchFamily="34" charset="-122"/>
-                <a:cs typeface="Calibri" pitchFamily="34" charset="-120"/>
-              </a:rPr>
-              <a:t> </a:t>
-            </a:r>
-            <a:r>
-              <a:rPr lang="en-US" sz="1500" dirty="0" err="1">
-                <a:solidFill>
-                  <a:srgbClr val="393D42"/>
-                </a:solidFill>
-                <a:latin typeface="Calibri" pitchFamily="34" charset="0"/>
-                <a:ea typeface="Calibri" pitchFamily="34" charset="-122"/>
-                <a:cs typeface="Calibri" pitchFamily="34" charset="-120"/>
-              </a:rPr>
-              <a:t>reconstruida</a:t>
-            </a:r>
-            <a:r>
-              <a:rPr lang="en-US" sz="1500" dirty="0">
-                <a:solidFill>
-                  <a:srgbClr val="393D42"/>
-                </a:solidFill>
-                <a:latin typeface="Calibri" pitchFamily="34" charset="0"/>
-                <a:ea typeface="Calibri" pitchFamily="34" charset="-122"/>
-                <a:cs typeface="Calibri" pitchFamily="34" charset="-120"/>
-              </a:rPr>
-              <a:t> desde commits y </a:t>
-            </a:r>
-            <a:r>
-              <a:rPr lang="en-US" sz="1500" dirty="0" err="1">
-                <a:solidFill>
-                  <a:srgbClr val="393D42"/>
-                </a:solidFill>
-                <a:latin typeface="Calibri" pitchFamily="34" charset="0"/>
-                <a:ea typeface="Calibri" pitchFamily="34" charset="-122"/>
-                <a:cs typeface="Calibri" pitchFamily="34" charset="-120"/>
-              </a:rPr>
-              <a:t>documento</a:t>
-            </a:r>
-            <a:r>
-              <a:rPr lang="en-US" sz="1500" dirty="0">
-                <a:solidFill>
-                  <a:srgbClr val="393D42"/>
-                </a:solidFill>
-                <a:latin typeface="Calibri" pitchFamily="34" charset="0"/>
-                <a:ea typeface="Calibri" pitchFamily="34" charset="-122"/>
-                <a:cs typeface="Calibri" pitchFamily="34" charset="-120"/>
-              </a:rPr>
-              <a:t> </a:t>
-            </a:r>
-            <a:r>
-              <a:rPr lang="en-US" sz="1500" i="1" dirty="0">
-                <a:solidFill>
-                  <a:srgbClr val="393D42"/>
-                </a:solidFill>
-                <a:latin typeface="Calibri" pitchFamily="34" charset="0"/>
-                <a:ea typeface="Calibri" pitchFamily="34" charset="-122"/>
-                <a:cs typeface="Calibri" pitchFamily="34" charset="-120"/>
-              </a:rPr>
-              <a:t>retrospectiva.md</a:t>
-            </a:r>
-            <a:r>
-              <a:rPr lang="en-US" sz="1500" dirty="0">
-                <a:solidFill>
-                  <a:srgbClr val="393D42"/>
-                </a:solidFill>
-                <a:latin typeface="Calibri" pitchFamily="34" charset="0"/>
-                <a:ea typeface="Calibri" pitchFamily="34" charset="-122"/>
-                <a:cs typeface="Calibri" pitchFamily="34" charset="-120"/>
-              </a:rPr>
+          </a:p>
+          <a:p>
+            <a:pPr marL="800100" lvl="1" indent="-342900">
+              <a:lnSpc>
+                <a:spcPct val="200000"/>
+              </a:lnSpc>
+              <a:buFont typeface="Wingdings" panose="05000000000000000000" pitchFamily="2" charset="2"/>
+              <a:buChar char="§"/>
+            </a:pPr>
+            <a:r>
+              <a:rPr lang="es-ES" sz="1600" dirty="0"/>
+              <a:t>El flujo avanza épica por épica; cada </a:t>
+            </a:r>
+            <a:r>
+              <a:rPr lang="es-ES" sz="1600" dirty="0" err="1"/>
+              <a:t>commit</a:t>
+            </a:r>
+            <a:r>
+              <a:rPr lang="es-ES" sz="1600" dirty="0"/>
+              <a:t> en Git registra el progreso como evidencia de proceso.</a:t>
+            </a:r>
+          </a:p>
+          <a:p>
+            <a:pPr marL="800100" lvl="1" indent="-342900">
+              <a:lnSpc>
+                <a:spcPct val="200000"/>
+              </a:lnSpc>
+              <a:buFont typeface="Wingdings" panose="05000000000000000000" pitchFamily="2" charset="2"/>
+              <a:buChar char="§"/>
+            </a:pPr>
+            <a:r>
+              <a:rPr lang="es-ES" dirty="0"/>
+              <a:t>Daily con Tech Leader y equipo de desarrollo para revisión de flujo.</a:t>
+            </a:r>
+          </a:p>
+          <a:p>
+            <a:pPr marL="800100" lvl="1" indent="-342900">
+              <a:lnSpc>
+                <a:spcPct val="200000"/>
+              </a:lnSpc>
+              <a:buFont typeface="Wingdings" panose="05000000000000000000" pitchFamily="2" charset="2"/>
+              <a:buChar char="§"/>
+            </a:pPr>
+            <a:r>
+              <a:rPr lang="es-ES" dirty="0"/>
+              <a:t>Reuniones con </a:t>
+            </a:r>
+            <a:r>
+              <a:rPr lang="es-ES" dirty="0" err="1"/>
+              <a:t>Product</a:t>
+            </a:r>
+            <a:r>
+              <a:rPr lang="es-ES" dirty="0"/>
+              <a:t> Owner según avance de épicas; ocasionalmente con </a:t>
+            </a:r>
+            <a:r>
+              <a:rPr lang="es-ES" dirty="0" err="1"/>
+              <a:t>Product</a:t>
+            </a:r>
+            <a:r>
+              <a:rPr lang="es-ES" dirty="0"/>
+              <a:t> Owner + cliente para validación y </a:t>
+            </a:r>
+            <a:r>
+              <a:rPr lang="es-ES" dirty="0" err="1"/>
+              <a:t>feedback</a:t>
+            </a:r>
+            <a:r>
+              <a:rPr lang="es-ES" dirty="0"/>
               <a:t>.</a:t>
             </a:r>
-            <a:endParaRPr lang="en-US" sz="1500" dirty="0"/>
-          </a:p>
-          <a:p>
-            <a:pPr marL="342900" indent="-342900">
-              <a:spcAft>
-                <a:spcPts val="1200"/>
-              </a:spcAft>
-              <a:buSzPct val="100000"/>
-              <a:buChar char="■"/>
-            </a:pPr>
-            <a:r>
-              <a:rPr lang="en-US" sz="1500" dirty="0">
-                <a:solidFill>
-                  <a:srgbClr val="393D42"/>
-                </a:solidFill>
-                <a:latin typeface="Calibri" pitchFamily="34" charset="0"/>
-                <a:ea typeface="Calibri" pitchFamily="34" charset="-122"/>
-                <a:cs typeface="Calibri" pitchFamily="34" charset="-120"/>
-              </a:rPr>
-              <a:t>Historial versionado en Git como evidencia de decisiones e impedimentos.</a:t>
-            </a:r>
-            <a:endParaRPr lang="en-US" sz="1500" dirty="0"/>
+          </a:p>
+          <a:p>
+            <a:pPr marL="800100" lvl="1" indent="-342900">
+              <a:lnSpc>
+                <a:spcPct val="200000"/>
+              </a:lnSpc>
+              <a:buFont typeface="Wingdings" panose="05000000000000000000" pitchFamily="2" charset="2"/>
+              <a:buChar char="§"/>
+            </a:pPr>
+            <a:r>
+              <a:rPr lang="es-ES" sz="1600" dirty="0" err="1"/>
+              <a:t>Commits</a:t>
+            </a:r>
+            <a:r>
+              <a:rPr lang="es-ES" sz="1600" dirty="0"/>
+              <a:t> etiquetados con ID de tarea para trazabilidad entre código y backlog en Jira.</a:t>
+            </a:r>
           </a:p>
         </p:txBody>
       </p:sp>
@@ -4619,7 +4555,18 @@
                 <a:ea typeface="Calibri" pitchFamily="34" charset="-122"/>
                 <a:cs typeface="Calibri" pitchFamily="34" charset="-120"/>
               </a:rPr>
-              <a:t>Desarrollo Full Stack, análisis y gestión del proyecto (trabajo individual)</a:t>
+              <a:t>Desarrollo Full Stack, análisis y gestión del </a:t>
+            </a:r>
+            <a:r>
+              <a:rPr lang="en-US" sz="1600" dirty="0" err="1">
+                <a:solidFill>
+                  <a:srgbClr val="393D42"/>
+                </a:solidFill>
+                <a:latin typeface="Calibri" pitchFamily="34" charset="0"/>
+                <a:ea typeface="Calibri" pitchFamily="34" charset="-122"/>
+                <a:cs typeface="Calibri" pitchFamily="34" charset="-120"/>
+              </a:rPr>
+              <a:t>proyecto</a:t>
             </a:r>
             <a:endParaRPr lang="en-US" sz="1600" dirty="0"/>
           </a:p>
@@ -5042,7 +4989,95 @@
                 <a:ea typeface="Calibri" pitchFamily="34" charset="-122"/>
                 <a:cs typeface="Calibri" pitchFamily="34" charset="-120"/>
               </a:rPr>
-              <a:t>La incorporación, traslado y desvinculación de trabajadores en cada obra afecta directamente el avance de los proyectos.</a:t>
+              <a:t>La incorporación, </a:t>
+            </a:r>
+            <a:r>
+              <a:rPr lang="en-US" sz="1600" dirty="0" err="1">
+                <a:solidFill>
+                  <a:srgbClr val="393D42"/>
+                </a:solidFill>
+                <a:latin typeface="Calibri" pitchFamily="34" charset="0"/>
+                <a:ea typeface="Calibri" pitchFamily="34" charset="-122"/>
+                <a:cs typeface="Calibri" pitchFamily="34" charset="-120"/>
+              </a:rPr>
+              <a:t>traspaso</a:t>
+            </a:r>
+            <a:r>
+              <a:rPr lang="en-US" sz="1600" dirty="0">
+                <a:solidFill>
+                  <a:srgbClr val="393D42"/>
+                </a:solidFill>
+                <a:latin typeface="Calibri" pitchFamily="34" charset="0"/>
+                <a:ea typeface="Calibri" pitchFamily="34" charset="-122"/>
+                <a:cs typeface="Calibri" pitchFamily="34" charset="-120"/>
+              </a:rPr>
+              <a:t> entre </a:t>
+            </a:r>
+            <a:r>
+              <a:rPr lang="en-US" sz="1600" dirty="0" err="1">
+                <a:solidFill>
+                  <a:srgbClr val="393D42"/>
+                </a:solidFill>
+                <a:latin typeface="Calibri" pitchFamily="34" charset="0"/>
+                <a:ea typeface="Calibri" pitchFamily="34" charset="-122"/>
+                <a:cs typeface="Calibri" pitchFamily="34" charset="-120"/>
+              </a:rPr>
+              <a:t>obras</a:t>
+            </a:r>
+            <a:r>
+              <a:rPr lang="en-US" sz="1600" dirty="0">
+                <a:solidFill>
+                  <a:srgbClr val="393D42"/>
+                </a:solidFill>
+                <a:latin typeface="Calibri" pitchFamily="34" charset="0"/>
+                <a:ea typeface="Calibri" pitchFamily="34" charset="-122"/>
+                <a:cs typeface="Calibri" pitchFamily="34" charset="-120"/>
+              </a:rPr>
+              <a:t> y desvinculación de </a:t>
+            </a:r>
+            <a:r>
+              <a:rPr lang="en-US" sz="1600" dirty="0" err="1">
+                <a:solidFill>
+                  <a:srgbClr val="393D42"/>
+                </a:solidFill>
+                <a:latin typeface="Calibri" pitchFamily="34" charset="0"/>
+                <a:ea typeface="Calibri" pitchFamily="34" charset="-122"/>
+                <a:cs typeface="Calibri" pitchFamily="34" charset="-120"/>
+              </a:rPr>
+              <a:t>trabajadores</a:t>
+            </a:r>
+            <a:r>
+              <a:rPr lang="en-US" sz="1600" dirty="0">
+                <a:solidFill>
+                  <a:srgbClr val="393D42"/>
+                </a:solidFill>
+                <a:latin typeface="Calibri" pitchFamily="34" charset="0"/>
+                <a:ea typeface="Calibri" pitchFamily="34" charset="-122"/>
+                <a:cs typeface="Calibri" pitchFamily="34" charset="-120"/>
+              </a:rPr>
+              <a:t> </a:t>
+            </a:r>
+            <a:r>
+              <a:rPr lang="en-US" sz="1600" dirty="0" err="1">
+                <a:solidFill>
+                  <a:srgbClr val="393D42"/>
+                </a:solidFill>
+                <a:latin typeface="Calibri" pitchFamily="34" charset="0"/>
+                <a:ea typeface="Calibri" pitchFamily="34" charset="-122"/>
+                <a:cs typeface="Calibri" pitchFamily="34" charset="-120"/>
+              </a:rPr>
+              <a:t>afecta</a:t>
+            </a:r>
+            <a:r>
+              <a:rPr lang="en-US" sz="1600" dirty="0">
+                <a:solidFill>
+                  <a:srgbClr val="393D42"/>
+                </a:solidFill>
+                <a:latin typeface="Calibri" pitchFamily="34" charset="0"/>
+                <a:ea typeface="Calibri" pitchFamily="34" charset="-122"/>
+                <a:cs typeface="Calibri" pitchFamily="34" charset="-120"/>
+              </a:rPr>
+              <a:t> directamente el avance de los proyectos.</a:t>
             </a:r>
             <a:endParaRPr lang="en-US" sz="1600" dirty="0"/>
           </a:p>
@@ -5305,7 +5340,29 @@
                 <a:ea typeface="Calibri" pitchFamily="34" charset="-122"/>
                 <a:cs typeface="Calibri" pitchFamily="34" charset="-120"/>
               </a:rPr>
-              <a:t>Las gestiones del ciclo de vida del trabajador —contratación, traslados, término de la relación laboral, permisos y vacaciones— se coordinan de forma informal entre la jefatura de obra y RRHH.</a:t>
+              <a:t>Las gestiones del ciclo de vida del trabajador —contratación, </a:t>
+            </a:r>
+            <a:r>
+              <a:rPr lang="en-US" sz="1700" dirty="0" err="1">
+                <a:solidFill>
+                  <a:srgbClr val="393D42"/>
+                </a:solidFill>
+                <a:latin typeface="Calibri" pitchFamily="34" charset="0"/>
+                <a:ea typeface="Calibri" pitchFamily="34" charset="-122"/>
+                <a:cs typeface="Calibri" pitchFamily="34" charset="-120"/>
+              </a:rPr>
+              <a:t>traspasos</a:t>
+            </a:r>
+            <a:r>
+              <a:rPr lang="en-US" sz="1700" dirty="0">
+                <a:solidFill>
+                  <a:srgbClr val="393D42"/>
+                </a:solidFill>
+                <a:latin typeface="Calibri" pitchFamily="34" charset="0"/>
+                <a:ea typeface="Calibri" pitchFamily="34" charset="-122"/>
+                <a:cs typeface="Calibri" pitchFamily="34" charset="-120"/>
+              </a:rPr>
+              <a:t>, término de la relación laboral, permisos y vacaciones— se coordinan de forma informal entre la jefatura de obra y RRHH.</a:t>
             </a:r>
             <a:endParaRPr lang="en-US" sz="1700" dirty="0"/>
           </a:p>
@@ -5347,7 +5404,29 @@
                 <a:ea typeface="Calibri" pitchFamily="34" charset="-122"/>
                 <a:cs typeface="Calibri" pitchFamily="34" charset="-120"/>
               </a:rPr>
-              <a:t>RRHH gestiona estos procesos de forma manual y, en paralelo, debe mantener alineado el sistema propio con el ERP externo para el cálculo de remuneraciones.</a:t>
+              <a:t>RRHH gestiona estos procesos de forma manual y, en paralelo, debe mantener alineado el sistema </a:t>
+            </a:r>
+            <a:r>
+              <a:rPr lang="en-US" sz="1700" dirty="0" err="1">
+                <a:solidFill>
+                  <a:srgbClr val="393D42"/>
+                </a:solidFill>
+                <a:latin typeface="Calibri" pitchFamily="34" charset="0"/>
+                <a:ea typeface="Calibri" pitchFamily="34" charset="-122"/>
+                <a:cs typeface="Calibri" pitchFamily="34" charset="-120"/>
+              </a:rPr>
+              <a:t>propio</a:t>
+            </a:r>
+            <a:r>
+              <a:rPr lang="en-US" sz="1700" dirty="0">
+                <a:solidFill>
+                  <a:srgbClr val="393D42"/>
+                </a:solidFill>
+                <a:latin typeface="Calibri" pitchFamily="34" charset="0"/>
+                <a:ea typeface="Calibri" pitchFamily="34" charset="-122"/>
+                <a:cs typeface="Calibri" pitchFamily="34" charset="-120"/>
+              </a:rPr>
+              <a:t> con el ERP externo para el cálculo de remuneraciones.</a:t>
             </a:r>
             <a:endParaRPr lang="en-US" sz="1700" dirty="0"/>
           </a:p>
@@ -5368,7 +5447,51 @@
                 <a:ea typeface="Calibri" pitchFamily="34" charset="-122"/>
                 <a:cs typeface="Calibri" pitchFamily="34" charset="-120"/>
               </a:rPr>
-              <a:t>Esto genera doble digitación, pérdida de trazabilidad y errores por falta de validación formal antes de aprobar cada solicitud.</a:t>
+              <a:t>Esto genera doble digitación, pérdida de </a:t>
+            </a:r>
+            <a:r>
+              <a:rPr lang="en-US" sz="1700" dirty="0" err="1">
+                <a:solidFill>
+                  <a:srgbClr val="393D42"/>
+                </a:solidFill>
+                <a:latin typeface="Calibri" pitchFamily="34" charset="0"/>
+                <a:ea typeface="Calibri" pitchFamily="34" charset="-122"/>
+                <a:cs typeface="Calibri" pitchFamily="34" charset="-120"/>
+              </a:rPr>
+              <a:t>trazabilidad</a:t>
+            </a:r>
+            <a:r>
+              <a:rPr lang="en-US" sz="1700" dirty="0">
+                <a:solidFill>
+                  <a:srgbClr val="393D42"/>
+                </a:solidFill>
+                <a:latin typeface="Calibri" pitchFamily="34" charset="0"/>
+                <a:ea typeface="Calibri" pitchFamily="34" charset="-122"/>
+                <a:cs typeface="Calibri" pitchFamily="34" charset="-120"/>
+              </a:rPr>
+              <a:t>, </a:t>
+            </a:r>
+            <a:r>
+              <a:rPr lang="en-US" sz="1700" dirty="0" err="1">
+                <a:solidFill>
+                  <a:srgbClr val="393D42"/>
+                </a:solidFill>
+                <a:latin typeface="Calibri" pitchFamily="34" charset="0"/>
+                <a:ea typeface="Calibri" pitchFamily="34" charset="-122"/>
+                <a:cs typeface="Calibri" pitchFamily="34" charset="-120"/>
+              </a:rPr>
+              <a:t>desorden</a:t>
+            </a:r>
+            <a:r>
+              <a:rPr lang="en-US" sz="1700" dirty="0">
+                <a:solidFill>
+                  <a:srgbClr val="393D42"/>
+                </a:solidFill>
+                <a:latin typeface="Calibri" pitchFamily="34" charset="0"/>
+                <a:ea typeface="Calibri" pitchFamily="34" charset="-122"/>
+                <a:cs typeface="Calibri" pitchFamily="34" charset="-120"/>
+              </a:rPr>
+              <a:t> y errores por falta de validación formal antes de aprobar cada solicitud.</a:t>
             </a:r>
             <a:endParaRPr lang="en-US" sz="1700" dirty="0"/>
           </a:p>
@@ -5853,7 +5976,51 @@
                 <a:ea typeface="Calibri" pitchFamily="34" charset="-122"/>
                 <a:cs typeface="Calibri" pitchFamily="34" charset="-120"/>
               </a:rPr>
-              <a:t>Jefatura de centro de costo → RRHH, con motivo de rechazo y corrección.</a:t>
+              <a:t>Jefatura de centro de costo → RRHH, con motivo de rechazo y </a:t>
+            </a:r>
+            <a:r>
+              <a:rPr lang="en-US" sz="1250" dirty="0" err="1">
+                <a:solidFill>
+                  <a:srgbClr val="393D42"/>
+                </a:solidFill>
+                <a:latin typeface="Calibri" pitchFamily="34" charset="0"/>
+                <a:ea typeface="Calibri" pitchFamily="34" charset="-122"/>
+                <a:cs typeface="Calibri" pitchFamily="34" charset="-120"/>
+              </a:rPr>
+              <a:t>opción</a:t>
+            </a:r>
+            <a:r>
+              <a:rPr lang="en-US" sz="1250" dirty="0">
+                <a:solidFill>
+                  <a:srgbClr val="393D42"/>
+                </a:solidFill>
+                <a:latin typeface="Calibri" pitchFamily="34" charset="0"/>
+                <a:ea typeface="Calibri" pitchFamily="34" charset="-122"/>
+                <a:cs typeface="Calibri" pitchFamily="34" charset="-120"/>
+              </a:rPr>
+              <a:t> de </a:t>
+            </a:r>
+            <a:r>
+              <a:rPr lang="en-US" sz="1250" dirty="0" err="1">
+                <a:solidFill>
+                  <a:srgbClr val="393D42"/>
+                </a:solidFill>
+                <a:latin typeface="Calibri" pitchFamily="34" charset="0"/>
+                <a:ea typeface="Calibri" pitchFamily="34" charset="-122"/>
+                <a:cs typeface="Calibri" pitchFamily="34" charset="-120"/>
+              </a:rPr>
+              <a:t>corregir</a:t>
+            </a:r>
+            <a:r>
+              <a:rPr lang="en-US" sz="1250" dirty="0">
+                <a:solidFill>
+                  <a:srgbClr val="393D42"/>
+                </a:solidFill>
+                <a:latin typeface="Calibri" pitchFamily="34" charset="0"/>
+                <a:ea typeface="Calibri" pitchFamily="34" charset="-122"/>
+                <a:cs typeface="Calibri" pitchFamily="34" charset="-120"/>
+              </a:rPr>
+              <a:t>.</a:t>
             </a:r>
             <a:endParaRPr lang="en-US" sz="1250" dirty="0"/>
           </a:p>
@@ -6117,7 +6284,73 @@
                 <a:ea typeface="Calibri" pitchFamily="34" charset="-122"/>
                 <a:cs typeface="Calibri" pitchFamily="34" charset="-120"/>
               </a:rPr>
-              <a:t>Simulada en este proyecto: evita que RRHH vuelva a digitar los datos aprobados.</a:t>
+              <a:t>Simulada en este proyecto: evita que RRHH vuelva a digitar los datos </a:t>
+            </a:r>
+            <a:r>
+              <a:rPr lang="en-US" sz="1250" dirty="0" err="1">
+                <a:solidFill>
+                  <a:srgbClr val="393D42"/>
+                </a:solidFill>
+                <a:latin typeface="Calibri" pitchFamily="34" charset="0"/>
+                <a:ea typeface="Calibri" pitchFamily="34" charset="-122"/>
+                <a:cs typeface="Calibri" pitchFamily="34" charset="-120"/>
+              </a:rPr>
+              <a:t>aprobados</a:t>
+            </a:r>
+            <a:r>
+              <a:rPr lang="en-US" sz="1250" dirty="0">
+                <a:solidFill>
+                  <a:srgbClr val="393D42"/>
+                </a:solidFill>
+                <a:latin typeface="Calibri" pitchFamily="34" charset="0"/>
+                <a:ea typeface="Calibri" pitchFamily="34" charset="-122"/>
+                <a:cs typeface="Calibri" pitchFamily="34" charset="-120"/>
+              </a:rPr>
+              <a:t>. (</a:t>
+            </a:r>
+            <a:r>
+              <a:rPr lang="en-US" sz="1250" dirty="0" err="1">
+                <a:solidFill>
+                  <a:srgbClr val="393D42"/>
+                </a:solidFill>
+                <a:latin typeface="Calibri" pitchFamily="34" charset="0"/>
+                <a:ea typeface="Calibri" pitchFamily="34" charset="-122"/>
+                <a:cs typeface="Calibri" pitchFamily="34" charset="-120"/>
+              </a:rPr>
+              <a:t>Integración</a:t>
+            </a:r>
+            <a:r>
+              <a:rPr lang="en-US" sz="1250" dirty="0">
+                <a:solidFill>
+                  <a:srgbClr val="393D42"/>
+                </a:solidFill>
+                <a:latin typeface="Calibri" pitchFamily="34" charset="0"/>
+                <a:ea typeface="Calibri" pitchFamily="34" charset="-122"/>
+                <a:cs typeface="Calibri" pitchFamily="34" charset="-120"/>
+              </a:rPr>
+              <a:t> con </a:t>
+            </a:r>
+            <a:r>
+              <a:rPr lang="en-US" sz="1250" dirty="0" err="1">
+                <a:solidFill>
+                  <a:srgbClr val="393D42"/>
+                </a:solidFill>
+                <a:latin typeface="Calibri" pitchFamily="34" charset="0"/>
+                <a:ea typeface="Calibri" pitchFamily="34" charset="-122"/>
+                <a:cs typeface="Calibri" pitchFamily="34" charset="-120"/>
+              </a:rPr>
+              <a:t>cliente</a:t>
+            </a:r>
+            <a:r>
+              <a:rPr lang="en-US" sz="1250" dirty="0">
+                <a:solidFill>
+                  <a:srgbClr val="393D42"/>
+                </a:solidFill>
+                <a:latin typeface="Calibri" pitchFamily="34" charset="0"/>
+                <a:ea typeface="Calibri" pitchFamily="34" charset="-122"/>
+                <a:cs typeface="Calibri" pitchFamily="34" charset="-120"/>
+              </a:rPr>
+              <a:t> stub)</a:t>
             </a:r>
             <a:endParaRPr lang="en-US" sz="1250" dirty="0"/>
           </a:p>
@@ -6683,135 +6916,13 @@
       </p:pic>
       <p:sp>
         <p:nvSpPr>
-          <p:cNvPr id="5" name="Shape 2"/>
-          <p:cNvSpPr/>
-          <p:nvPr/>
-        </p:nvSpPr>
-        <p:spPr>
-          <a:xfrm>
-            <a:off x="548640" y="1463040"/>
-            <a:ext cx="6876837" cy="4480560"/>
-          </a:xfrm>
-          <a:prstGeom prst="rect">
-            <a:avLst/>
-          </a:prstGeom>
-          <a:solidFill>
-            <a:srgbClr val="F4F4F5"/>
-          </a:solidFill>
-          <a:ln w="12700">
-            <a:solidFill>
-              <a:srgbClr val="9CA3AF"/>
-            </a:solidFill>
-            <a:prstDash val="dash"/>
-          </a:ln>
-        </p:spPr>
-        <p:txBody>
-          <a:bodyPr/>
-          <a:lstStyle/>
-          <a:p>
-            <a:endParaRPr lang="es-ES"/>
-          </a:p>
-        </p:txBody>
-      </p:sp>
-      <p:sp>
-        <p:nvSpPr>
-          <p:cNvPr id="6" name="Text 3"/>
-          <p:cNvSpPr txBox="1"/>
-          <p:nvPr/>
-        </p:nvSpPr>
-        <p:spPr>
-          <a:xfrm>
-            <a:off x="548640" y="1463040"/>
-            <a:ext cx="6876837" cy="4480560"/>
-          </a:xfrm>
-          <a:prstGeom prst="rect">
-            <a:avLst/>
-          </a:prstGeom>
-          <a:noFill/>
-          <a:ln/>
-        </p:spPr>
-        <p:txBody>
-          <a:bodyPr wrap="square" lIns="0" tIns="0" rIns="0" bIns="0" rtlCol="0" anchor="ctr"/>
-          <a:lstStyle/>
-          <a:p>
-            <a:pPr marL="0" indent="0" algn="ctr">
-              <a:buNone/>
-            </a:pPr>
-            <a:r>
-              <a:rPr lang="en-US" sz="1400" i="1" dirty="0">
-                <a:solidFill>
-                  <a:srgbClr val="9CA3AF"/>
-                </a:solidFill>
-                <a:latin typeface="Calibri" pitchFamily="34" charset="0"/>
-                <a:ea typeface="Calibri" pitchFamily="34" charset="-122"/>
-                <a:cs typeface="Calibri" pitchFamily="34" charset="-120"/>
-              </a:rPr>
-              <a:t>[pega captura del diagrama</a:t>
-            </a:r>
-            <a:endParaRPr lang="en-US" sz="1400" dirty="0"/>
-          </a:p>
-          <a:p>
-            <a:pPr marL="0" indent="0" algn="ctr">
-              <a:buNone/>
-            </a:pPr>
-            <a:r>
-              <a:rPr lang="en-US" sz="1400" i="1" dirty="0">
-                <a:solidFill>
-                  <a:srgbClr val="9CA3AF"/>
-                </a:solidFill>
-                <a:latin typeface="Calibri" pitchFamily="34" charset="0"/>
-                <a:ea typeface="Calibri" pitchFamily="34" charset="-122"/>
-                <a:cs typeface="Calibri" pitchFamily="34" charset="-120"/>
-              </a:rPr>
-              <a:t>de dbdiagram.io aquí</a:t>
-            </a:r>
-            <a:endParaRPr lang="en-US" sz="1400" dirty="0"/>
-          </a:p>
-          <a:p>
-            <a:pPr marL="0" indent="0" algn="ctr">
-              <a:buNone/>
-            </a:pPr>
-            <a:r>
-              <a:rPr lang="en-US" sz="1400" i="1" dirty="0">
-                <a:solidFill>
-                  <a:srgbClr val="9CA3AF"/>
-                </a:solidFill>
-                <a:latin typeface="Calibri" pitchFamily="34" charset="0"/>
-                <a:ea typeface="Calibri" pitchFamily="34" charset="-122"/>
-                <a:cs typeface="Calibri" pitchFamily="34" charset="-120"/>
-              </a:rPr>
-              <a:t>— actualizar antes con el</a:t>
-            </a:r>
-            <a:endParaRPr lang="en-US" sz="1400" dirty="0"/>
-          </a:p>
-          <a:p>
-            <a:pPr marL="0" indent="0" algn="ctr">
-              <a:buNone/>
-            </a:pPr>
-            <a:r>
-              <a:rPr lang="en-US" sz="1400" i="1" dirty="0">
-                <a:solidFill>
-                  <a:srgbClr val="9CA3AF"/>
-                </a:solidFill>
-                <a:latin typeface="Calibri" pitchFamily="34" charset="0"/>
-                <a:ea typeface="Calibri" pitchFamily="34" charset="-122"/>
-                <a:cs typeface="Calibri" pitchFamily="34" charset="-120"/>
-              </a:rPr>
-              <a:t>script DBML más reciente]</a:t>
-            </a:r>
-            <a:endParaRPr lang="en-US" sz="1400" dirty="0"/>
-          </a:p>
-        </p:txBody>
-      </p:sp>
-      <p:sp>
-        <p:nvSpPr>
           <p:cNvPr id="7" name="Text 4"/>
           <p:cNvSpPr txBox="1"/>
           <p:nvPr/>
         </p:nvSpPr>
         <p:spPr>
           <a:xfrm>
-            <a:off x="7791237" y="1463040"/>
+            <a:off x="777240" y="1645920"/>
             <a:ext cx="3849075" cy="365760"/>
           </a:xfrm>
           <a:prstGeom prst="rect">
@@ -6850,7 +6961,7 @@
         </p:nvSpPr>
         <p:spPr>
           <a:xfrm>
-            <a:off x="7791237" y="1920240"/>
+            <a:off x="777240" y="2103120"/>
             <a:ext cx="3849075" cy="4114800"/>
           </a:xfrm>
           <a:prstGeom prst="rect">
@@ -6997,7 +7108,7 @@
               <a:buChar char="■"/>
             </a:pPr>
             <a:r>
-              <a:rPr lang="en-US" sz="1350" dirty="0">
+              <a:rPr lang="en-US" sz="1350" dirty="0" err="1">
                 <a:solidFill>
                   <a:srgbClr val="393D42"/>
                 </a:solidFill>
@@ -7007,6 +7118,55 @@
               </a:rPr>
               <a:t>Remuneraciones</a:t>
             </a:r>
+            <a:endParaRPr lang="en-US" sz="1350" dirty="0">
+              <a:solidFill>
+                <a:srgbClr val="393D42"/>
+              </a:solidFill>
+              <a:latin typeface="Calibri" pitchFamily="34" charset="0"/>
+              <a:ea typeface="Calibri" pitchFamily="34" charset="-122"/>
+              <a:cs typeface="Calibri" pitchFamily="34" charset="-120"/>
+            </a:endParaRPr>
+          </a:p>
+          <a:p>
+            <a:pPr marL="342900" indent="-342900">
+              <a:spcAft>
+                <a:spcPts val="1000"/>
+              </a:spcAft>
+              <a:buSzPct val="100000"/>
+              <a:buChar char="■"/>
+            </a:pPr>
+            <a:endParaRPr lang="en-US" sz="1350" dirty="0">
+              <a:solidFill>
+                <a:srgbClr val="393D42"/>
+              </a:solidFill>
+              <a:latin typeface="Calibri" pitchFamily="34" charset="0"/>
+              <a:ea typeface="Calibri" pitchFamily="34" charset="-122"/>
+              <a:cs typeface="Calibri" pitchFamily="34" charset="-120"/>
+            </a:endParaRPr>
+          </a:p>
+          <a:p>
+            <a:pPr>
+              <a:spcAft>
+                <a:spcPts val="1000"/>
+              </a:spcAft>
+              <a:buSzPct val="100000"/>
+            </a:pPr>
+            <a:r>
+              <a:rPr lang="en-US" sz="1100" i="1" dirty="0">
+                <a:hlinkClick r:id="rId4"/>
+              </a:rPr>
+              <a:t>https://dbdiagram.io/d/Promaty-Modelo-Datos-6ab60b6e0f25a52d0103c261</a:t>
+            </a:r>
+            <a:endParaRPr lang="en-US" sz="1100" i="1" dirty="0"/>
+          </a:p>
+          <a:p>
+            <a:pPr marL="342900" indent="-342900">
+              <a:spcAft>
+                <a:spcPts val="1000"/>
+              </a:spcAft>
+              <a:buSzPct val="100000"/>
+              <a:buChar char="■"/>
+            </a:pPr>
             <a:endParaRPr lang="en-US" sz="1350" dirty="0"/>
           </a:p>
         </p:txBody>
@@ -7024,7 +7184,7 @@
           <p:nvPr/>
         </p:nvPicPr>
         <p:blipFill>
-          <a:blip r:embed="rId4">
+          <a:blip r:embed="rId5">
             <a:alphaModFix/>
           </a:blip>
           <a:stretch>
@@ -7043,6 +7203,36 @@
           <a:ln>
             <a:noFill/>
           </a:ln>
+        </p:spPr>
+      </p:pic>
+      <p:pic>
+        <p:nvPicPr>
+          <p:cNvPr id="12" name="Imagen 11">
+            <a:extLst>
+              <a:ext uri="{FF2B5EF4-FFF2-40B4-BE49-F238E27FC236}">
+                <a16:creationId xmlns:a16="http://schemas.microsoft.com/office/drawing/2014/main" id="{243527B7-C23C-CC8A-6B70-70DCFB2F2427}"/>
+              </a:ext>
+            </a:extLst>
+          </p:cNvPr>
+          <p:cNvPicPr>
+            <a:picLocks noChangeAspect="1"/>
+          </p:cNvPicPr>
+          <p:nvPr/>
+        </p:nvPicPr>
+        <p:blipFill>
+          <a:blip r:embed="rId6"/>
+          <a:stretch>
+            <a:fillRect/>
+          </a:stretch>
+        </p:blipFill>
+        <p:spPr>
+          <a:xfrm>
+            <a:off x="6887965" y="743141"/>
+            <a:ext cx="3177488" cy="5840539"/>
+          </a:xfrm>
+          <a:prstGeom prst="rect">
+            <a:avLst/>
+          </a:prstGeom>
         </p:spPr>
       </p:pic>
     </p:spTree>
@@ -7168,77 +7358,6 @@
           </a:prstGeom>
         </p:spPr>
       </p:pic>
-      <p:sp>
-        <p:nvSpPr>
-          <p:cNvPr id="5" name="Shape 2"/>
-          <p:cNvSpPr/>
-          <p:nvPr/>
-        </p:nvSpPr>
-        <p:spPr>
-          <a:xfrm>
-            <a:off x="548640" y="1463040"/>
-            <a:ext cx="11091672" cy="4480560"/>
-          </a:xfrm>
-          <a:prstGeom prst="rect">
-            <a:avLst/>
-          </a:prstGeom>
-          <a:solidFill>
-            <a:srgbClr val="F4F4F5"/>
-          </a:solidFill>
-          <a:ln w="12700">
-            <a:solidFill>
-              <a:srgbClr val="9CA3AF"/>
-            </a:solidFill>
-            <a:prstDash val="dash"/>
-          </a:ln>
-        </p:spPr>
-        <p:txBody>
-          <a:bodyPr/>
-          <a:lstStyle/>
-          <a:p>
-            <a:endParaRPr lang="es-ES"/>
-          </a:p>
-        </p:txBody>
-      </p:sp>
-      <p:sp>
-        <p:nvSpPr>
-          <p:cNvPr id="6" name="Text 3"/>
-          <p:cNvSpPr txBox="1"/>
-          <p:nvPr/>
-        </p:nvSpPr>
-        <p:spPr>
-          <a:xfrm>
-            <a:off x="548640" y="1463040"/>
-            <a:ext cx="11091672" cy="4480560"/>
-          </a:xfrm>
-          <a:prstGeom prst="rect">
-            <a:avLst/>
-          </a:prstGeom>
-          <a:noFill/>
-          <a:ln/>
-        </p:spPr>
-        <p:txBody>
-          <a:bodyPr wrap="square" lIns="0" tIns="0" rIns="0" bIns="0" rtlCol="0" anchor="ctr"/>
-          <a:lstStyle/>
-          <a:p>
-            <a:pPr marL="0" indent="0" algn="ctr">
-              <a:buNone/>
-            </a:pPr>
-            <a:r>
-              <a:rPr lang="en-US" sz="1400" i="1" dirty="0">
-                <a:solidFill>
-                  <a:srgbClr val="9CA3AF"/>
-                </a:solidFill>
-                <a:latin typeface="Calibri" pitchFamily="34" charset="0"/>
-                <a:ea typeface="Calibri" pitchFamily="34" charset="-122"/>
-                <a:cs typeface="Calibri" pitchFamily="34" charset="-120"/>
-              </a:rPr>
-              <a:t>[pega diagrama de arquitectura (jpg) aquí]</a:t>
-            </a:r>
-            <a:endParaRPr lang="en-US" sz="1400" dirty="0"/>
-          </a:p>
-        </p:txBody>
-      </p:sp>
       <p:pic>
         <p:nvPicPr>
           <p:cNvPr id="8" name="Google Shape;119;p1">
@@ -7271,6 +7390,36 @@
           <a:ln>
             <a:noFill/>
           </a:ln>
+        </p:spPr>
+      </p:pic>
+      <p:pic>
+        <p:nvPicPr>
+          <p:cNvPr id="9" name="Imagen 8">
+            <a:extLst>
+              <a:ext uri="{FF2B5EF4-FFF2-40B4-BE49-F238E27FC236}">
+                <a16:creationId xmlns:a16="http://schemas.microsoft.com/office/drawing/2014/main" id="{B7C730A6-F675-0364-72E3-588CA1C27162}"/>
+              </a:ext>
+            </a:extLst>
+          </p:cNvPr>
+          <p:cNvPicPr>
+            <a:picLocks noChangeAspect="1"/>
+          </p:cNvPicPr>
+          <p:nvPr/>
+        </p:nvPicPr>
+        <p:blipFill>
+          <a:blip r:embed="rId5"/>
+          <a:stretch>
+            <a:fillRect/>
+          </a:stretch>
+        </p:blipFill>
+        <p:spPr>
+          <a:xfrm>
+            <a:off x="2342741" y="1294466"/>
+            <a:ext cx="8163334" cy="5378836"/>
+          </a:xfrm>
+          <a:prstGeom prst="rect">
+            <a:avLst/>
+          </a:prstGeom>
         </p:spPr>
       </p:pic>
     </p:spTree>

</xml_diff>